<commit_message>
fix: architecture PNGs no longer bottom-clipped (element capture); dedupe ensemble quote; regenerate report PDF
</commit_message>
<xml_diff>
--- a/deck/Early_Disease_Prediction_System.pptx
+++ b/deck/Early_Disease_Prediction_System.pptx
@@ -7530,8 +7530,8 @@
         </p:blipFill>
         <p:spPr>
           <a:xfrm>
-            <a:off x="502920" y="1481328"/>
-            <a:ext cx="7406640" cy="2999232"/>
+            <a:off x="502920" y="1920240"/>
+            <a:ext cx="7406640" cy="2121408"/>
           </a:xfrm>
           <a:prstGeom prst="rect">
             <a:avLst/>

</xml_diff>